<commit_message>
Add CPS physics-aware detection engine and update writeup
Monitor now tracks physical process state from Modbus traffic and
validates every write against plant constraints:
- Register bounds (valve 0-180°, tank 0-1023 ADC)
- Pump oscillation detection (Stuxnet-style toggling <5s)
- Sensor spoofing (writes to read-only registers)
- Valve/pump state consistency
- Unsafe commands (pump ON above 85%, OFF below 30%)
- Rate-of-change limits based on physical fill/drain rates

Writeup updated with:
- CPS physics engine in detection design and forensic results
- ICS-specific dataset discussion (SWaT, Mississippi State SCADA,
  WADI, BATADAL, HAI) as alternative training approach
- Updated conclusion, recommendations, and references

Presentation slides updated to reflect 4-layer detection pipeline.
</commit_message>
<xml_diff>
--- a/presentation/CPS-IDS-Presentation.pptx
+++ b/presentation/CPS-IDS-Presentation.pptx
@@ -4518,7 +4518,7 @@
         </p:nvSpPr>
         <p:spPr>
           <a:xfrm>
-            <a:off x="914400" y="1828800"/>
+            <a:off x="457200" y="1828800"/>
             <a:ext cx="2194560" cy="1371600"/>
           </a:xfrm>
           <a:prstGeom prst="roundRect">
@@ -4562,7 +4562,7 @@
         </p:nvSpPr>
         <p:spPr>
           <a:xfrm>
-            <a:off x="914400" y="1828800"/>
+            <a:off x="457200" y="1828800"/>
             <a:ext cx="73152" cy="1371600"/>
           </a:xfrm>
           <a:prstGeom prst="rect">
@@ -4605,7 +4605,7 @@
         </p:nvSpPr>
         <p:spPr>
           <a:xfrm>
-            <a:off x="1097280" y="1965960"/>
+            <a:off x="640080" y="1965960"/>
             <a:ext cx="1920240" cy="640080"/>
           </a:xfrm>
           <a:prstGeom prst="rect">
@@ -4641,7 +4641,7 @@
         </p:nvSpPr>
         <p:spPr>
           <a:xfrm>
-            <a:off x="1097280" y="2606040"/>
+            <a:off x="640080" y="2606040"/>
             <a:ext cx="1920240" cy="548640"/>
           </a:xfrm>
           <a:prstGeom prst="rect">
@@ -4685,7 +4685,7 @@
         </p:nvSpPr>
         <p:spPr>
           <a:xfrm>
-            <a:off x="3657600" y="1828800"/>
+            <a:off x="2926080" y="1828800"/>
             <a:ext cx="2194560" cy="1371600"/>
           </a:xfrm>
           <a:prstGeom prst="roundRect">
@@ -4729,7 +4729,7 @@
         </p:nvSpPr>
         <p:spPr>
           <a:xfrm>
-            <a:off x="3657600" y="1828800"/>
+            <a:off x="2926080" y="1828800"/>
             <a:ext cx="73152" cy="1371600"/>
           </a:xfrm>
           <a:prstGeom prst="rect">
@@ -4772,7 +4772,7 @@
         </p:nvSpPr>
         <p:spPr>
           <a:xfrm>
-            <a:off x="3840480" y="1965960"/>
+            <a:off x="3108960" y="1965960"/>
             <a:ext cx="1920240" cy="640080"/>
           </a:xfrm>
           <a:prstGeom prst="rect">
@@ -4808,7 +4808,7 @@
         </p:nvSpPr>
         <p:spPr>
           <a:xfrm>
-            <a:off x="3840480" y="2606040"/>
+            <a:off x="3108960" y="2606040"/>
             <a:ext cx="1920240" cy="548640"/>
           </a:xfrm>
           <a:prstGeom prst="rect">
@@ -4852,7 +4852,7 @@
         </p:nvSpPr>
         <p:spPr>
           <a:xfrm>
-            <a:off x="6400800" y="1828800"/>
+            <a:off x="5394960" y="1828800"/>
             <a:ext cx="2194560" cy="1371600"/>
           </a:xfrm>
           <a:prstGeom prst="roundRect">
@@ -4896,14 +4896,14 @@
         </p:nvSpPr>
         <p:spPr>
           <a:xfrm>
-            <a:off x="6400800" y="1828800"/>
+            <a:off x="5394960" y="1828800"/>
             <a:ext cx="73152" cy="1371600"/>
           </a:xfrm>
           <a:prstGeom prst="rect">
             <a:avLst/>
           </a:prstGeom>
           <a:solidFill>
-            <a:srgbClr val="065F46"/>
+            <a:srgbClr val="E94560"/>
           </a:solidFill>
           <a:ln>
             <a:noFill/>
@@ -4939,7 +4939,7 @@
         </p:nvSpPr>
         <p:spPr>
           <a:xfrm>
-            <a:off x="6583680" y="1965960"/>
+            <a:off x="5577840" y="1965960"/>
             <a:ext cx="1920240" cy="640080"/>
           </a:xfrm>
           <a:prstGeom prst="rect">
@@ -4956,13 +4956,13 @@
             <a:pPr algn="ctr">
               <a:defRPr sz="3200" b="1">
                 <a:solidFill>
-                  <a:srgbClr val="065F46"/>
+                  <a:srgbClr val="E94560"/>
                 </a:solidFill>
                 <a:latin typeface="Calibri"/>
               </a:defRPr>
             </a:pPr>
             <a:r>
-              <a:t>3</a:t>
+              <a:t>6</a:t>
             </a:r>
           </a:p>
         </p:txBody>
@@ -4975,7 +4975,7 @@
         </p:nvSpPr>
         <p:spPr>
           <a:xfrm>
-            <a:off x="6583680" y="2606040"/>
+            <a:off x="5577840" y="2606040"/>
             <a:ext cx="1920240" cy="548640"/>
           </a:xfrm>
           <a:prstGeom prst="rect">
@@ -4998,15 +4998,15 @@
               </a:defRPr>
             </a:pPr>
             <a:r>
-              <a:t>ML Models</a:t>
+              <a:t>CPS Physics Checks</a:t>
             </a:r>
             <a:br/>
             <a:r>
-              <a:t>Random Forest, CNN+LSTM</a:t>
+              <a:t>Register bounds, pump</a:t>
             </a:r>
             <a:br/>
             <a:r>
-              <a:t>Isolation Forest</a:t>
+              <a:t>oscillation, spoofing</a:t>
             </a:r>
           </a:p>
         </p:txBody>
@@ -5019,7 +5019,7 @@
         </p:nvSpPr>
         <p:spPr>
           <a:xfrm>
-            <a:off x="9144000" y="1828800"/>
+            <a:off x="7863840" y="1828800"/>
             <a:ext cx="2194560" cy="1371600"/>
           </a:xfrm>
           <a:prstGeom prst="roundRect">
@@ -5063,14 +5063,14 @@
         </p:nvSpPr>
         <p:spPr>
           <a:xfrm>
-            <a:off x="9144000" y="1828800"/>
+            <a:off x="7863840" y="1828800"/>
             <a:ext cx="73152" cy="1371600"/>
           </a:xfrm>
           <a:prstGeom prst="rect">
             <a:avLst/>
           </a:prstGeom>
           <a:solidFill>
-            <a:srgbClr val="E94560"/>
+            <a:srgbClr val="065F46"/>
           </a:solidFill>
           <a:ln>
             <a:noFill/>
@@ -5106,7 +5106,7 @@
         </p:nvSpPr>
         <p:spPr>
           <a:xfrm>
-            <a:off x="9326880" y="1965960"/>
+            <a:off x="8046719" y="1965960"/>
             <a:ext cx="1920240" cy="640080"/>
           </a:xfrm>
           <a:prstGeom prst="rect">
@@ -5123,13 +5123,13 @@
             <a:pPr algn="ctr">
               <a:defRPr sz="3200" b="1">
                 <a:solidFill>
-                  <a:srgbClr val="E94560"/>
+                  <a:srgbClr val="065F46"/>
                 </a:solidFill>
                 <a:latin typeface="Calibri"/>
               </a:defRPr>
             </a:pPr>
             <a:r>
-              <a:t>78</a:t>
+              <a:t>3</a:t>
             </a:r>
           </a:p>
         </p:txBody>
@@ -5142,7 +5142,7 @@
         </p:nvSpPr>
         <p:spPr>
           <a:xfrm>
-            <a:off x="9326880" y="2606040"/>
+            <a:off x="8046719" y="2606040"/>
             <a:ext cx="1920240" cy="548640"/>
           </a:xfrm>
           <a:prstGeom prst="rect">
@@ -5165,15 +5165,15 @@
               </a:defRPr>
             </a:pPr>
             <a:r>
-              <a:t>Flow Features</a:t>
+              <a:t>ML Models</a:t>
             </a:r>
             <a:br/>
             <a:r>
-              <a:t>Extracted per flow for</a:t>
+              <a:t>Random Forest, CNN+LSTM</a:t>
             </a:r>
             <a:br/>
             <a:r>
-              <a:t>CNN+LSTM inference</a:t>
+              <a:t>Isolation Forest</a:t>
             </a:r>
           </a:p>
         </p:txBody>
@@ -5209,7 +5209,7 @@
               </a:defRPr>
             </a:pPr>
             <a:r>
-              <a:t>Detection Pipeline:   Rule Engine  →  Modbus Analysis  →  CNN+LSTM Inference</a:t>
+              <a:t>Detection Pipeline:   Rule Engine  →  Modbus Analysis  →  CPS Physics  →  CNN+LSTM Inference</a:t>
             </a:r>
           </a:p>
         </p:txBody>
@@ -8596,7 +8596,7 @@
               </a:defRPr>
             </a:pPr>
             <a:r>
-              <a:t>Modbus-Specific Detection</a:t>
+              <a:t>CPS-Specific Detection</a:t>
             </a:r>
           </a:p>
         </p:txBody>
@@ -8610,7 +8610,7 @@
         <p:spPr>
           <a:xfrm>
             <a:off x="457200" y="4389120"/>
-            <a:ext cx="5486400" cy="1645920"/>
+            <a:ext cx="5486400" cy="2011680"/>
           </a:xfrm>
           <a:prstGeom prst="rect">
             <a:avLst/>
@@ -8630,7 +8630,7 @@
               <a:spcAft>
                 <a:spcPts val="200"/>
               </a:spcAft>
-              <a:defRPr sz="1500">
+              <a:defRPr sz="1400">
                 <a:solidFill>
                   <a:srgbClr val="1A1A2E"/>
                 </a:solidFill>
@@ -8649,7 +8649,7 @@
               <a:spcAft>
                 <a:spcPts val="200"/>
               </a:spcAft>
-              <a:defRPr sz="1500">
+              <a:defRPr sz="1400">
                 <a:solidFill>
                   <a:srgbClr val="1A1A2E"/>
                 </a:solidFill>
@@ -8668,7 +8668,7 @@
               <a:spcAft>
                 <a:spcPts val="200"/>
               </a:spcAft>
-              <a:defRPr sz="1500">
+              <a:defRPr sz="1400">
                 <a:solidFill>
                   <a:srgbClr val="1A1A2E"/>
                 </a:solidFill>
@@ -8676,7 +8676,64 @@
               </a:defRPr>
             </a:pPr>
             <a:r>
-              <a:t>•  Domain-adapted classifier for Modbus flow patterns</a:t>
+              <a:t>•  Physics engine: register bounds (valve 0–180°, tank 0–1023)</a:t>
+            </a:r>
+          </a:p>
+          <a:p>
+            <a:pPr>
+              <a:spcBef>
+                <a:spcPts val="400"/>
+              </a:spcBef>
+              <a:spcAft>
+                <a:spcPts val="200"/>
+              </a:spcAft>
+              <a:defRPr sz="1400">
+                <a:solidFill>
+                  <a:srgbClr val="1A1A2E"/>
+                </a:solidFill>
+                <a:latin typeface="Calibri"/>
+              </a:defRPr>
+            </a:pPr>
+            <a:r>
+              <a:t>•  Pump oscillation: detects Stuxnet-style rapid toggling (&lt;5s)</a:t>
+            </a:r>
+          </a:p>
+          <a:p>
+            <a:pPr>
+              <a:spcBef>
+                <a:spcPts val="400"/>
+              </a:spcBef>
+              <a:spcAft>
+                <a:spcPts val="200"/>
+              </a:spcAft>
+              <a:defRPr sz="1400">
+                <a:solidFill>
+                  <a:srgbClr val="1A1A2E"/>
+                </a:solidFill>
+                <a:latin typeface="Calibri"/>
+              </a:defRPr>
+            </a:pPr>
+            <a:r>
+              <a:t>•  Sensor spoofing: flags direct writes to read-only registers</a:t>
+            </a:r>
+          </a:p>
+          <a:p>
+            <a:pPr>
+              <a:spcBef>
+                <a:spcPts val="400"/>
+              </a:spcBef>
+              <a:spcAft>
+                <a:spcPts val="200"/>
+              </a:spcAft>
+              <a:defRPr sz="1400">
+                <a:solidFill>
+                  <a:srgbClr val="1A1A2E"/>
+                </a:solidFill>
+                <a:latin typeface="Calibri"/>
+              </a:defRPr>
+            </a:pPr>
+            <a:r>
+              <a:t>•  State consistency: valve/pump mismatch, unsafe commands</a:t>
             </a:r>
           </a:p>
         </p:txBody>

</xml_diff>

<commit_message>
Update presentation with 8 attacks, CPS physics results, Wireshark refs
- Slide 7: Added Attack 8 (Stuxnet rootkit MitM) to attack table
- Slide 8: Updated stats (264 CPS physics, 320 write-rate, 13,109
  flood), added CPS column to coverage table, Wireshark references
- Slide 9: 4-layer defence-in-depth
- Slide 10: 8/8 attacks detected
</commit_message>
<xml_diff>
--- a/presentation/CPS-IDS-Presentation.pptx
+++ b/presentation/CPS-IDS-Presentation.pptx
@@ -3897,7 +3897,7 @@
               </a:defRPr>
             </a:pPr>
             <a:r>
-              <a:t>7 / 7</a:t>
+              <a:t>8 / 8</a:t>
             </a:r>
           </a:p>
         </p:txBody>
@@ -4013,7 +4013,7 @@
               </a:defRPr>
             </a:pPr>
             <a:r>
-              <a:t>•  Deployed live IDS monitor with real-time ONNX inference (~1ms per prediction)</a:t>
+              <a:t>•  Deployed live IDS monitor with CPS physics engine and real-time ONNX inference (~1ms)</a:t>
             </a:r>
           </a:p>
           <a:p>
@@ -4032,7 +4032,7 @@
               </a:defRPr>
             </a:pPr>
             <a:r>
-              <a:t>•  Conducted forensic investigation detecting all 7 attack types across 3 detection layers</a:t>
+              <a:t>•  Conducted forensic investigation detecting all 8 attacks (incl. Stuxnet MitM) across 4 layers</a:t>
             </a:r>
           </a:p>
           <a:p>
@@ -9284,7 +9284,7 @@
               </a:defRPr>
             </a:pPr>
             <a:r>
-              <a:t>7 attacks executed via automated pipeline (tmux + tcpdump + IDS + attack runner)</a:t>
+              <a:t>8 attacks executed via automated pipeline (incl. Stuxnet MitM rootkit)</a:t>
             </a:r>
           </a:p>
         </p:txBody>
@@ -9299,7 +9299,7 @@
         </p:nvGraphicFramePr>
         <p:xfrm>
           <a:off x="457200" y="1554480"/>
-          <a:ext cx="11247120" cy="3657600"/>
+          <a:ext cx="11247120" cy="4114800"/>
         </p:xfrm>
         <a:graphic>
           <a:graphicData uri="http://schemas.openxmlformats.org/drawingml/2006/table">
@@ -10210,6 +10210,128 @@
                   <a:tcPr/>
                 </a:tc>
               </a:tr>
+              <a:tr h="457200">
+                <a:tc>
+                  <a:txBody>
+                    <a:bodyPr/>
+                    <a:lstStyle/>
+                    <a:p>
+                      <a:pPr algn="ctr">
+                        <a:defRPr sz="1200">
+                          <a:solidFill>
+                            <a:srgbClr val="1A1A2E"/>
+                          </a:solidFill>
+                          <a:latin typeface="Calibri"/>
+                        </a:defRPr>
+                      </a:pPr>
+                      <a:r>
+                        <a:t>8</a:t>
+                      </a:r>
+                    </a:p>
+                  </a:txBody>
+                  <a:tcPr>
+                    <a:solidFill>
+                      <a:srgbClr val="F5F5F5"/>
+                    </a:solidFill>
+                  </a:tcPr>
+                </a:tc>
+                <a:tc>
+                  <a:txBody>
+                    <a:bodyPr/>
+                    <a:lstStyle/>
+                    <a:p>
+                      <a:pPr algn="ctr">
+                        <a:defRPr sz="1200">
+                          <a:solidFill>
+                            <a:srgbClr val="1A1A2E"/>
+                          </a:solidFill>
+                          <a:latin typeface="Calibri"/>
+                        </a:defRPr>
+                      </a:pPr>
+                      <a:r>
+                        <a:t>Stuxnet Rootkit (MitM)</a:t>
+                      </a:r>
+                    </a:p>
+                  </a:txBody>
+                  <a:tcPr>
+                    <a:solidFill>
+                      <a:srgbClr val="F5F5F5"/>
+                    </a:solidFill>
+                  </a:tcPr>
+                </a:tc>
+                <a:tc>
+                  <a:txBody>
+                    <a:bodyPr/>
+                    <a:lstStyle/>
+                    <a:p>
+                      <a:pPr algn="ctr">
+                        <a:defRPr sz="1200">
+                          <a:solidFill>
+                            <a:srgbClr val="1A1A2E"/>
+                          </a:solidFill>
+                          <a:latin typeface="Calibri"/>
+                        </a:defRPr>
+                      </a:pPr>
+                      <a:r>
+                        <a:t>Mixed</a:t>
+                      </a:r>
+                    </a:p>
+                  </a:txBody>
+                  <a:tcPr>
+                    <a:solidFill>
+                      <a:srgbClr val="F5F5F5"/>
+                    </a:solidFill>
+                  </a:tcPr>
+                </a:tc>
+                <a:tc>
+                  <a:txBody>
+                    <a:bodyPr/>
+                    <a:lstStyle/>
+                    <a:p>
+                      <a:pPr algn="ctr">
+                        <a:defRPr sz="1200">
+                          <a:solidFill>
+                            <a:srgbClr val="1A1A2E"/>
+                          </a:solidFill>
+                          <a:latin typeface="Calibri"/>
+                        </a:defRPr>
+                      </a:pPr>
+                      <a:r>
+                        <a:t>60s</a:t>
+                      </a:r>
+                    </a:p>
+                  </a:txBody>
+                  <a:tcPr>
+                    <a:solidFill>
+                      <a:srgbClr val="F5F5F5"/>
+                    </a:solidFill>
+                  </a:tcPr>
+                </a:tc>
+                <a:tc>
+                  <a:txBody>
+                    <a:bodyPr/>
+                    <a:lstStyle/>
+                    <a:p>
+                      <a:pPr algn="ctr">
+                        <a:defRPr sz="1200">
+                          <a:solidFill>
+                            <a:srgbClr val="1A1A2E"/>
+                          </a:solidFill>
+                          <a:latin typeface="Calibri"/>
+                        </a:defRPr>
+                      </a:pPr>
+                      <a:r>
+                        <a:t>Intermittent actuator manipulation + sensor falsification</a:t>
+                      </a:r>
+                    </a:p>
+                  </a:txBody>
+                  <a:tcPr>
+                    <a:solidFill>
+                      <a:srgbClr val="F5F5F5"/>
+                    </a:solidFill>
+                  </a:tcPr>
+                </a:tc>
+              </a:tr>
             </a:tbl>
           </a:graphicData>
         </a:graphic>
@@ -10222,7 +10344,7 @@
         </p:nvSpPr>
         <p:spPr>
           <a:xfrm>
-            <a:off x="457200" y="5394960"/>
+            <a:off x="457200" y="5852160"/>
             <a:ext cx="11247120" cy="731520"/>
           </a:xfrm>
           <a:prstGeom prst="rect">
@@ -10237,7 +10359,7 @@
           <a:lstStyle/>
           <a:p>
             <a:pPr algn="ctr">
-              <a:defRPr sz="1500" b="0">
+              <a:defRPr sz="1400" b="0">
                 <a:solidFill>
                   <a:srgbClr val="666666"/>
                 </a:solidFill>
@@ -10245,7 +10367,7 @@
               </a:defRPr>
             </a:pPr>
             <a:r>
-              <a:t>Evidence captured:  full-session.pcap (tcpdump)  |  alerts.jsonl (IDS)  |  attack-manifest.json (timestamps)</a:t>
+              <a:t>Evidence:  pcap (tcpdump)  |  alerts.jsonl (IDS)  |  attack-manifest.json  |  system artifacts (processes, connections, PLC registers)</a:t>
             </a:r>
           </a:p>
         </p:txBody>
@@ -10312,7 +10434,7 @@
         </p:nvSpPr>
         <p:spPr>
           <a:xfrm>
-            <a:off x="731520" y="1554480"/>
+            <a:off x="457200" y="1554480"/>
             <a:ext cx="2194560" cy="1371600"/>
           </a:xfrm>
           <a:prstGeom prst="roundRect">
@@ -10356,7 +10478,7 @@
         </p:nvSpPr>
         <p:spPr>
           <a:xfrm>
-            <a:off x="731520" y="1554480"/>
+            <a:off x="457200" y="1554480"/>
             <a:ext cx="73152" cy="1371600"/>
           </a:xfrm>
           <a:prstGeom prst="rect">
@@ -10399,7 +10521,7 @@
         </p:nvSpPr>
         <p:spPr>
           <a:xfrm>
-            <a:off x="914400" y="1691639"/>
+            <a:off x="640080" y="1691639"/>
             <a:ext cx="1920240" cy="640080"/>
           </a:xfrm>
           <a:prstGeom prst="rect">
@@ -10435,7 +10557,7 @@
         </p:nvSpPr>
         <p:spPr>
           <a:xfrm>
-            <a:off x="914400" y="2331720"/>
+            <a:off x="640080" y="2331720"/>
             <a:ext cx="1920240" cy="548640"/>
           </a:xfrm>
           <a:prstGeom prst="rect">
@@ -10462,7 +10584,7 @@
             </a:r>
             <a:br/>
             <a:r>
-              <a:t>Across all 7 attacks</a:t>
+              <a:t>Across all 8 attacks</a:t>
             </a:r>
           </a:p>
         </p:txBody>
@@ -10475,7 +10597,7 @@
         </p:nvSpPr>
         <p:spPr>
           <a:xfrm>
-            <a:off x="3200400" y="1554480"/>
+            <a:off x="2743200" y="1554480"/>
             <a:ext cx="2194560" cy="1371600"/>
           </a:xfrm>
           <a:prstGeom prst="roundRect">
@@ -10519,14 +10641,14 @@
         </p:nvSpPr>
         <p:spPr>
           <a:xfrm>
-            <a:off x="3200400" y="1554480"/>
+            <a:off x="2743200" y="1554480"/>
             <a:ext cx="73152" cy="1371600"/>
           </a:xfrm>
           <a:prstGeom prst="rect">
             <a:avLst/>
           </a:prstGeom>
           <a:solidFill>
-            <a:srgbClr val="92400E"/>
+            <a:srgbClr val="E94560"/>
           </a:solidFill>
           <a:ln>
             <a:noFill/>
@@ -10562,7 +10684,7 @@
         </p:nvSpPr>
         <p:spPr>
           <a:xfrm>
-            <a:off x="3383280" y="1691639"/>
+            <a:off x="2926080" y="1691639"/>
             <a:ext cx="1920240" cy="640080"/>
           </a:xfrm>
           <a:prstGeom prst="rect">
@@ -10579,13 +10701,13 @@
             <a:pPr algn="ctr">
               <a:defRPr sz="3200" b="1">
                 <a:solidFill>
-                  <a:srgbClr val="92400E"/>
+                  <a:srgbClr val="E94560"/>
                 </a:solidFill>
                 <a:latin typeface="Calibri"/>
               </a:defRPr>
             </a:pPr>
             <a:r>
-              <a:t>300</a:t>
+              <a:t>264</a:t>
             </a:r>
           </a:p>
         </p:txBody>
@@ -10598,7 +10720,7 @@
         </p:nvSpPr>
         <p:spPr>
           <a:xfrm>
-            <a:off x="3383280" y="2331720"/>
+            <a:off x="2926080" y="2331720"/>
             <a:ext cx="1920240" cy="548640"/>
           </a:xfrm>
           <a:prstGeom prst="rect">
@@ -10621,11 +10743,15 @@
               </a:defRPr>
             </a:pPr>
             <a:r>
-              <a:t>Write-Rate Alerts</a:t>
+              <a:t>CPS Physics Alerts</a:t>
             </a:r>
             <a:br/>
             <a:r>
-              <a:t>Modbus anomaly detection</a:t>
+              <a:t>Oscillation, spoofing,</a:t>
+            </a:r>
+            <a:br/>
+            <a:r>
+              <a:t>mismatch</a:t>
             </a:r>
           </a:p>
         </p:txBody>
@@ -10638,7 +10764,7 @@
         </p:nvSpPr>
         <p:spPr>
           <a:xfrm>
-            <a:off x="5669280" y="1554480"/>
+            <a:off x="5029200" y="1554480"/>
             <a:ext cx="2194560" cy="1371600"/>
           </a:xfrm>
           <a:prstGeom prst="roundRect">
@@ -10682,14 +10808,14 @@
         </p:nvSpPr>
         <p:spPr>
           <a:xfrm>
-            <a:off x="5669280" y="1554480"/>
+            <a:off x="5029200" y="1554480"/>
             <a:ext cx="73152" cy="1371600"/>
           </a:xfrm>
           <a:prstGeom prst="rect">
             <a:avLst/>
           </a:prstGeom>
           <a:solidFill>
-            <a:srgbClr val="1E40AF"/>
+            <a:srgbClr val="92400E"/>
           </a:solidFill>
           <a:ln>
             <a:noFill/>
@@ -10725,7 +10851,7 @@
         </p:nvSpPr>
         <p:spPr>
           <a:xfrm>
-            <a:off x="5852160" y="1691639"/>
+            <a:off x="5212080" y="1691639"/>
             <a:ext cx="1920240" cy="640080"/>
           </a:xfrm>
           <a:prstGeom prst="rect">
@@ -10742,13 +10868,13 @@
             <a:pPr algn="ctr">
               <a:defRPr sz="3200" b="1">
                 <a:solidFill>
-                  <a:srgbClr val="1E40AF"/>
+                  <a:srgbClr val="92400E"/>
                 </a:solidFill>
                 <a:latin typeface="Calibri"/>
               </a:defRPr>
             </a:pPr>
             <a:r>
-              <a:t>8,126</a:t>
+              <a:t>320</a:t>
             </a:r>
           </a:p>
         </p:txBody>
@@ -10761,7 +10887,7 @@
         </p:nvSpPr>
         <p:spPr>
           <a:xfrm>
-            <a:off x="5852160" y="2331720"/>
+            <a:off x="5212080" y="2331720"/>
             <a:ext cx="1920240" cy="548640"/>
           </a:xfrm>
           <a:prstGeom prst="rect">
@@ -10784,25 +10910,112 @@
               </a:defRPr>
             </a:pPr>
             <a:r>
-              <a:t>Flood Detection</a:t>
+              <a:t>Write-Rate Alerts</a:t>
             </a:r>
             <a:br/>
             <a:r>
-              <a:t>DoS &amp; multi-stage attacks</a:t>
-            </a:r>
-          </a:p>
-        </p:txBody>
-      </p:sp>
-      <p:sp>
-        <p:nvSpPr>
-          <p:cNvPr id="15" name="TextBox 14"/>
+              <a:t>Modbus anomaly</a:t>
+            </a:r>
+          </a:p>
+        </p:txBody>
+      </p:sp>
+      <p:sp>
+        <p:nvSpPr>
+          <p:cNvPr id="15" name="Rounded Rectangle 14"/>
+          <p:cNvSpPr/>
+          <p:nvPr/>
+        </p:nvSpPr>
+        <p:spPr>
+          <a:xfrm>
+            <a:off x="7315200" y="1554480"/>
+            <a:ext cx="2194560" cy="1371600"/>
+          </a:xfrm>
+          <a:prstGeom prst="roundRect">
+            <a:avLst/>
+          </a:prstGeom>
+          <a:solidFill>
+            <a:srgbClr val="F8F9FA"/>
+          </a:solidFill>
+          <a:ln>
+            <a:noFill/>
+          </a:ln>
+          <a:effectLst/>
+        </p:spPr>
+        <p:style>
+          <a:lnRef idx="1">
+            <a:schemeClr val="accent1"/>
+          </a:lnRef>
+          <a:fillRef idx="3">
+            <a:schemeClr val="accent1"/>
+          </a:fillRef>
+          <a:effectRef idx="2">
+            <a:schemeClr val="accent1"/>
+          </a:effectRef>
+          <a:fontRef idx="minor">
+            <a:schemeClr val="lt1"/>
+          </a:fontRef>
+        </p:style>
+        <p:txBody>
+          <a:bodyPr rtlCol="0" anchor="ctr"/>
+          <a:lstStyle/>
+          <a:p>
+            <a:pPr algn="ctr"/>
+          </a:p>
+        </p:txBody>
+      </p:sp>
+      <p:sp>
+        <p:nvSpPr>
+          <p:cNvPr id="16" name="Rectangle 15"/>
+          <p:cNvSpPr/>
+          <p:nvPr/>
+        </p:nvSpPr>
+        <p:spPr>
+          <a:xfrm>
+            <a:off x="7315200" y="1554480"/>
+            <a:ext cx="73152" cy="1371600"/>
+          </a:xfrm>
+          <a:prstGeom prst="rect">
+            <a:avLst/>
+          </a:prstGeom>
+          <a:solidFill>
+            <a:srgbClr val="1E40AF"/>
+          </a:solidFill>
+          <a:ln>
+            <a:noFill/>
+          </a:ln>
+        </p:spPr>
+        <p:style>
+          <a:lnRef idx="1">
+            <a:schemeClr val="accent1"/>
+          </a:lnRef>
+          <a:fillRef idx="3">
+            <a:schemeClr val="accent1"/>
+          </a:fillRef>
+          <a:effectRef idx="2">
+            <a:schemeClr val="accent1"/>
+          </a:effectRef>
+          <a:fontRef idx="minor">
+            <a:schemeClr val="lt1"/>
+          </a:fontRef>
+        </p:style>
+        <p:txBody>
+          <a:bodyPr rtlCol="0" anchor="ctr"/>
+          <a:lstStyle/>
+          <a:p>
+            <a:pPr algn="ctr"/>
+          </a:p>
+        </p:txBody>
+      </p:sp>
+      <p:sp>
+        <p:nvSpPr>
+          <p:cNvPr id="17" name="TextBox 16"/>
           <p:cNvSpPr txBox="1"/>
           <p:nvPr/>
         </p:nvSpPr>
         <p:spPr>
           <a:xfrm>
-            <a:off x="8686800" y="1554480"/>
-            <a:ext cx="3017520" cy="365760"/>
+            <a:off x="7498079" y="1691639"/>
+            <a:ext cx="1920240" cy="640080"/>
           </a:xfrm>
           <a:prstGeom prst="rect">
             <a:avLst/>
@@ -10815,8 +11028,84 @@
           </a:bodyPr>
           <a:lstStyle/>
           <a:p>
+            <a:pPr algn="ctr">
+              <a:defRPr sz="3200" b="1">
+                <a:solidFill>
+                  <a:srgbClr val="1E40AF"/>
+                </a:solidFill>
+                <a:latin typeface="Calibri"/>
+              </a:defRPr>
+            </a:pPr>
+            <a:r>
+              <a:t>13,109</a:t>
+            </a:r>
+          </a:p>
+        </p:txBody>
+      </p:sp>
+      <p:sp>
+        <p:nvSpPr>
+          <p:cNvPr id="18" name="TextBox 17"/>
+          <p:cNvSpPr txBox="1"/>
+          <p:nvPr/>
+        </p:nvSpPr>
+        <p:spPr>
+          <a:xfrm>
+            <a:off x="7498079" y="2331720"/>
+            <a:ext cx="1920240" cy="548640"/>
+          </a:xfrm>
+          <a:prstGeom prst="rect">
+            <a:avLst/>
+          </a:prstGeom>
+          <a:noFill/>
+        </p:spPr>
+        <p:txBody>
+          <a:bodyPr wrap="square">
+            <a:spAutoFit/>
+          </a:bodyPr>
+          <a:lstStyle/>
+          <a:p>
+            <a:pPr algn="ctr">
+              <a:defRPr sz="1100" b="0">
+                <a:solidFill>
+                  <a:srgbClr val="666666"/>
+                </a:solidFill>
+                <a:latin typeface="Calibri"/>
+              </a:defRPr>
+            </a:pPr>
+            <a:r>
+              <a:t>Flood Detection</a:t>
+            </a:r>
+            <a:br/>
+            <a:r>
+              <a:t>DoS &amp; multi-stage</a:t>
+            </a:r>
+          </a:p>
+        </p:txBody>
+      </p:sp>
+      <p:sp>
+        <p:nvSpPr>
+          <p:cNvPr id="19" name="TextBox 18"/>
+          <p:cNvSpPr txBox="1"/>
+          <p:nvPr/>
+        </p:nvSpPr>
+        <p:spPr>
+          <a:xfrm>
+            <a:off x="9875520" y="1554480"/>
+            <a:ext cx="2011680" cy="365760"/>
+          </a:xfrm>
+          <a:prstGeom prst="rect">
+            <a:avLst/>
+          </a:prstGeom>
+          <a:noFill/>
+        </p:spPr>
+        <p:txBody>
+          <a:bodyPr wrap="square">
+            <a:spAutoFit/>
+          </a:bodyPr>
+          <a:lstStyle/>
+          <a:p>
             <a:pPr algn="l">
-              <a:defRPr sz="1800" b="1">
+              <a:defRPr sz="1600" b="1">
                 <a:solidFill>
                   <a:srgbClr val="1A1A2E"/>
                 </a:solidFill>
@@ -10824,22 +11113,22 @@
               </a:defRPr>
             </a:pPr>
             <a:r>
-              <a:t>Detection Coverage</a:t>
+              <a:t>Coverage</a:t>
             </a:r>
           </a:p>
         </p:txBody>
       </p:sp>
       <p:graphicFrame>
         <p:nvGraphicFramePr>
-          <p:cNvPr id="16" name="Table 15"/>
+          <p:cNvPr id="20" name="Table 19"/>
           <p:cNvGraphicFramePr>
             <a:graphicFrameLocks noGrp="1"/>
           </p:cNvGraphicFramePr>
           <p:nvPr/>
         </p:nvGraphicFramePr>
         <p:xfrm>
-          <a:off x="8686800" y="2011680"/>
-          <a:ext cx="3017520" cy="3200400"/>
+          <a:off x="9601200" y="2011680"/>
+          <a:ext cx="2286000" cy="3474720"/>
         </p:xfrm>
         <a:graphic>
           <a:graphicData uri="http://schemas.openxmlformats.org/drawingml/2006/table">
@@ -10848,12 +11137,11 @@
                 <a:tableStyleId>{5C22544A-7EE6-4342-B048-85BDC9FD1C3A}</a:tableStyleId>
               </a:tblPr>
               <a:tblGrid>
-                <a:gridCol w="1188720"/>
-                <a:gridCol w="548640"/>
-                <a:gridCol w="731520"/>
-                <a:gridCol w="548640"/>
+                <a:gridCol w="1005840"/>
+                <a:gridCol w="640080"/>
+                <a:gridCol w="640080"/>
               </a:tblGrid>
-              <a:tr h="400050">
+              <a:tr h="386080">
                 <a:tc>
                   <a:txBody>
                     <a:bodyPr/>
@@ -10892,7 +11180,7 @@
                         </a:defRPr>
                       </a:pPr>
                       <a:r>
-                        <a:t>Rule</a:t>
+                        <a:t>CPS</a:t>
                       </a:r>
                     </a:p>
                   </a:txBody>
@@ -10916,7 +11204,7 @@
                         </a:defRPr>
                       </a:pPr>
                       <a:r>
-                        <a:t>Modbus</a:t>
+                        <a:t>ML</a:t>
                       </a:r>
                     </a:p>
                   </a:txBody>
@@ -10926,47 +11214,23 @@
                     </a:solidFill>
                   </a:tcPr>
                 </a:tc>
-                <a:tc>
-                  <a:txBody>
-                    <a:bodyPr/>
-                    <a:lstStyle/>
-                    <a:p>
-                      <a:pPr algn="ctr">
-                        <a:defRPr sz="1200" b="1">
-                          <a:solidFill>
-                            <a:srgbClr val="FFFFFF"/>
-                          </a:solidFill>
-                          <a:latin typeface="Calibri"/>
-                        </a:defRPr>
-                      </a:pPr>
-                      <a:r>
-                        <a:t>ML</a:t>
-                      </a:r>
-                    </a:p>
-                  </a:txBody>
-                  <a:tcPr>
-                    <a:solidFill>
-                      <a:srgbClr val="1A1A2E"/>
-                    </a:solidFill>
-                  </a:tcPr>
-                </a:tc>
               </a:tr>
-              <a:tr h="400050">
-                <a:tc>
-                  <a:txBody>
-                    <a:bodyPr/>
-                    <a:lstStyle/>
-                    <a:p>
-                      <a:pPr algn="ctr">
-                        <a:defRPr sz="1200">
-                          <a:solidFill>
-                            <a:srgbClr val="1A1A2E"/>
-                          </a:solidFill>
-                          <a:latin typeface="Calibri"/>
-                        </a:defRPr>
-                      </a:pPr>
-                      <a:r>
-                        <a:t>Cmd Injection</a:t>
+              <a:tr h="386080">
+                <a:tc>
+                  <a:txBody>
+                    <a:bodyPr/>
+                    <a:lstStyle/>
+                    <a:p>
+                      <a:pPr algn="ctr">
+                        <a:defRPr sz="1200">
+                          <a:solidFill>
+                            <a:srgbClr val="1A1A2E"/>
+                          </a:solidFill>
+                          <a:latin typeface="Calibri"/>
+                        </a:defRPr>
+                      </a:pPr>
+                      <a:r>
+                        <a:t>Cmd Inject</a:t>
                       </a:r>
                     </a:p>
                   </a:txBody>
@@ -10985,6 +11249,23 @@
                           <a:latin typeface="Calibri"/>
                         </a:defRPr>
                       </a:pPr>
+                    </a:p>
+                  </a:txBody>
+                  <a:tcPr/>
+                </a:tc>
+                <a:tc>
+                  <a:txBody>
+                    <a:bodyPr/>
+                    <a:lstStyle/>
+                    <a:p>
+                      <a:pPr algn="ctr">
+                        <a:defRPr sz="1200">
+                          <a:solidFill>
+                            <a:srgbClr val="1A1A2E"/>
+                          </a:solidFill>
+                          <a:latin typeface="Calibri"/>
+                        </a:defRPr>
+                      </a:pPr>
                       <a:r>
                         <a:t>✓</a:t>
                       </a:r>
@@ -10992,63 +11273,23 @@
                   </a:txBody>
                   <a:tcPr/>
                 </a:tc>
-                <a:tc>
-                  <a:txBody>
-                    <a:bodyPr/>
-                    <a:lstStyle/>
-                    <a:p>
-                      <a:pPr algn="ctr">
-                        <a:defRPr sz="1200">
-                          <a:solidFill>
-                            <a:srgbClr val="1A1A2E"/>
-                          </a:solidFill>
-                          <a:latin typeface="Calibri"/>
-                        </a:defRPr>
-                      </a:pPr>
-                      <a:r>
-                        <a:t>✓</a:t>
-                      </a:r>
-                    </a:p>
-                  </a:txBody>
-                  <a:tcPr/>
-                </a:tc>
-                <a:tc>
-                  <a:txBody>
-                    <a:bodyPr/>
-                    <a:lstStyle/>
-                    <a:p>
-                      <a:pPr algn="ctr">
-                        <a:defRPr sz="1200">
-                          <a:solidFill>
-                            <a:srgbClr val="1A1A2E"/>
-                          </a:solidFill>
-                          <a:latin typeface="Calibri"/>
-                        </a:defRPr>
-                      </a:pPr>
-                      <a:r>
-                        <a:t>✓</a:t>
-                      </a:r>
-                    </a:p>
-                  </a:txBody>
-                  <a:tcPr/>
-                </a:tc>
               </a:tr>
-              <a:tr h="400050">
-                <a:tc>
-                  <a:txBody>
-                    <a:bodyPr/>
-                    <a:lstStyle/>
-                    <a:p>
-                      <a:pPr algn="ctr">
-                        <a:defRPr sz="1200">
-                          <a:solidFill>
-                            <a:srgbClr val="1A1A2E"/>
-                          </a:solidFill>
-                          <a:latin typeface="Calibri"/>
-                        </a:defRPr>
-                      </a:pPr>
-                      <a:r>
-                        <a:t>Pump Oscillation</a:t>
+              <a:tr h="386080">
+                <a:tc>
+                  <a:txBody>
+                    <a:bodyPr/>
+                    <a:lstStyle/>
+                    <a:p>
+                      <a:pPr algn="ctr">
+                        <a:defRPr sz="1200">
+                          <a:solidFill>
+                            <a:srgbClr val="1A1A2E"/>
+                          </a:solidFill>
+                          <a:latin typeface="Calibri"/>
+                        </a:defRPr>
+                      </a:pPr>
+                      <a:r>
+                        <a:t>Oscillation</a:t>
                       </a:r>
                     </a:p>
                   </a:txBody>
@@ -11106,6 +11347,28 @@
                     </a:solidFill>
                   </a:tcPr>
                 </a:tc>
+              </a:tr>
+              <a:tr h="386080">
+                <a:tc>
+                  <a:txBody>
+                    <a:bodyPr/>
+                    <a:lstStyle/>
+                    <a:p>
+                      <a:pPr algn="ctr">
+                        <a:defRPr sz="1200">
+                          <a:solidFill>
+                            <a:srgbClr val="1A1A2E"/>
+                          </a:solidFill>
+                          <a:latin typeface="Calibri"/>
+                        </a:defRPr>
+                      </a:pPr>
+                      <a:r>
+                        <a:t>Valve Manip</a:t>
+                      </a:r>
+                    </a:p>
+                  </a:txBody>
+                  <a:tcPr/>
+                </a:tc>
                 <a:tc>
                   <a:txBody>
                     <a:bodyPr/>
@@ -11121,6 +11384,48 @@
                       </a:pPr>
                       <a:r>
                         <a:t>✓</a:t>
+                      </a:r>
+                    </a:p>
+                  </a:txBody>
+                  <a:tcPr/>
+                </a:tc>
+                <a:tc>
+                  <a:txBody>
+                    <a:bodyPr/>
+                    <a:lstStyle/>
+                    <a:p>
+                      <a:pPr algn="ctr">
+                        <a:defRPr sz="1200">
+                          <a:solidFill>
+                            <a:srgbClr val="1A1A2E"/>
+                          </a:solidFill>
+                          <a:latin typeface="Calibri"/>
+                        </a:defRPr>
+                      </a:pPr>
+                      <a:r>
+                        <a:t>✓</a:t>
+                      </a:r>
+                    </a:p>
+                  </a:txBody>
+                  <a:tcPr/>
+                </a:tc>
+              </a:tr>
+              <a:tr h="386080">
+                <a:tc>
+                  <a:txBody>
+                    <a:bodyPr/>
+                    <a:lstStyle/>
+                    <a:p>
+                      <a:pPr algn="ctr">
+                        <a:defRPr sz="1200">
+                          <a:solidFill>
+                            <a:srgbClr val="1A1A2E"/>
+                          </a:solidFill>
+                          <a:latin typeface="Calibri"/>
+                        </a:defRPr>
+                      </a:pPr>
+                      <a:r>
+                        <a:t>Replay</a:t>
                       </a:r>
                     </a:p>
                   </a:txBody>
@@ -11130,28 +11435,6 @@
                     </a:solidFill>
                   </a:tcPr>
                 </a:tc>
-              </a:tr>
-              <a:tr h="400050">
-                <a:tc>
-                  <a:txBody>
-                    <a:bodyPr/>
-                    <a:lstStyle/>
-                    <a:p>
-                      <a:pPr algn="ctr">
-                        <a:defRPr sz="1200">
-                          <a:solidFill>
-                            <a:srgbClr val="1A1A2E"/>
-                          </a:solidFill>
-                          <a:latin typeface="Calibri"/>
-                        </a:defRPr>
-                      </a:pPr>
-                      <a:r>
-                        <a:t>Valve Manip.</a:t>
-                      </a:r>
-                    </a:p>
-                  </a:txBody>
-                  <a:tcPr/>
-                </a:tc>
                 <a:tc>
                   <a:txBody>
                     <a:bodyPr/>
@@ -11167,68 +11450,6 @@
                       </a:pPr>
                       <a:r>
                         <a:t>✓</a:t>
-                      </a:r>
-                    </a:p>
-                  </a:txBody>
-                  <a:tcPr/>
-                </a:tc>
-                <a:tc>
-                  <a:txBody>
-                    <a:bodyPr/>
-                    <a:lstStyle/>
-                    <a:p>
-                      <a:pPr algn="ctr">
-                        <a:defRPr sz="1200">
-                          <a:solidFill>
-                            <a:srgbClr val="1A1A2E"/>
-                          </a:solidFill>
-                          <a:latin typeface="Calibri"/>
-                        </a:defRPr>
-                      </a:pPr>
-                      <a:r>
-                        <a:t>✓</a:t>
-                      </a:r>
-                    </a:p>
-                  </a:txBody>
-                  <a:tcPr/>
-                </a:tc>
-                <a:tc>
-                  <a:txBody>
-                    <a:bodyPr/>
-                    <a:lstStyle/>
-                    <a:p>
-                      <a:pPr algn="ctr">
-                        <a:defRPr sz="1200">
-                          <a:solidFill>
-                            <a:srgbClr val="1A1A2E"/>
-                          </a:solidFill>
-                          <a:latin typeface="Calibri"/>
-                        </a:defRPr>
-                      </a:pPr>
-                      <a:r>
-                        <a:t>✓</a:t>
-                      </a:r>
-                    </a:p>
-                  </a:txBody>
-                  <a:tcPr/>
-                </a:tc>
-              </a:tr>
-              <a:tr h="400050">
-                <a:tc>
-                  <a:txBody>
-                    <a:bodyPr/>
-                    <a:lstStyle/>
-                    <a:p>
-                      <a:pPr algn="ctr">
-                        <a:defRPr sz="1200">
-                          <a:solidFill>
-                            <a:srgbClr val="1A1A2E"/>
-                          </a:solidFill>
-                          <a:latin typeface="Calibri"/>
-                        </a:defRPr>
-                      </a:pPr>
-                      <a:r>
-                        <a:t>Replay</a:t>
                       </a:r>
                     </a:p>
                   </a:txBody>
@@ -11262,6 +11483,28 @@
                     </a:solidFill>
                   </a:tcPr>
                 </a:tc>
+              </a:tr>
+              <a:tr h="386080">
+                <a:tc>
+                  <a:txBody>
+                    <a:bodyPr/>
+                    <a:lstStyle/>
+                    <a:p>
+                      <a:pPr algn="ctr">
+                        <a:defRPr sz="1200">
+                          <a:solidFill>
+                            <a:srgbClr val="1A1A2E"/>
+                          </a:solidFill>
+                          <a:latin typeface="Calibri"/>
+                        </a:defRPr>
+                      </a:pPr>
+                      <a:r>
+                        <a:t>Spoofing</a:t>
+                      </a:r>
+                    </a:p>
+                  </a:txBody>
+                  <a:tcPr/>
+                </a:tc>
                 <a:tc>
                   <a:txBody>
                     <a:bodyPr/>
@@ -11277,6 +11520,48 @@
                       </a:pPr>
                       <a:r>
                         <a:t>✓</a:t>
+                      </a:r>
+                    </a:p>
+                  </a:txBody>
+                  <a:tcPr/>
+                </a:tc>
+                <a:tc>
+                  <a:txBody>
+                    <a:bodyPr/>
+                    <a:lstStyle/>
+                    <a:p>
+                      <a:pPr algn="ctr">
+                        <a:defRPr sz="1200">
+                          <a:solidFill>
+                            <a:srgbClr val="1A1A2E"/>
+                          </a:solidFill>
+                          <a:latin typeface="Calibri"/>
+                        </a:defRPr>
+                      </a:pPr>
+                      <a:r>
+                        <a:t>✓</a:t>
+                      </a:r>
+                    </a:p>
+                  </a:txBody>
+                  <a:tcPr/>
+                </a:tc>
+              </a:tr>
+              <a:tr h="386080">
+                <a:tc>
+                  <a:txBody>
+                    <a:bodyPr/>
+                    <a:lstStyle/>
+                    <a:p>
+                      <a:pPr algn="ctr">
+                        <a:defRPr sz="1200">
+                          <a:solidFill>
+                            <a:srgbClr val="1A1A2E"/>
+                          </a:solidFill>
+                          <a:latin typeface="Calibri"/>
+                        </a:defRPr>
+                      </a:pPr>
+                      <a:r>
+                        <a:t>Flood</a:t>
                       </a:r>
                     </a:p>
                   </a:txBody>
@@ -11299,9 +11584,6 @@
                           <a:latin typeface="Calibri"/>
                         </a:defRPr>
                       </a:pPr>
-                      <a:r>
-                        <a:t>✓</a:t>
-                      </a:r>
                     </a:p>
                   </a:txBody>
                   <a:tcPr>
@@ -11310,28 +11592,6 @@
                     </a:solidFill>
                   </a:tcPr>
                 </a:tc>
-              </a:tr>
-              <a:tr h="400050">
-                <a:tc>
-                  <a:txBody>
-                    <a:bodyPr/>
-                    <a:lstStyle/>
-                    <a:p>
-                      <a:pPr algn="ctr">
-                        <a:defRPr sz="1200">
-                          <a:solidFill>
-                            <a:srgbClr val="1A1A2E"/>
-                          </a:solidFill>
-                          <a:latin typeface="Calibri"/>
-                        </a:defRPr>
-                      </a:pPr>
-                      <a:r>
-                        <a:t>Sensor Spoof</a:t>
-                      </a:r>
-                    </a:p>
-                  </a:txBody>
-                  <a:tcPr/>
-                </a:tc>
                 <a:tc>
                   <a:txBody>
                     <a:bodyPr/>
@@ -11347,68 +11607,6 @@
                       </a:pPr>
                       <a:r>
                         <a:t>✓</a:t>
-                      </a:r>
-                    </a:p>
-                  </a:txBody>
-                  <a:tcPr/>
-                </a:tc>
-                <a:tc>
-                  <a:txBody>
-                    <a:bodyPr/>
-                    <a:lstStyle/>
-                    <a:p>
-                      <a:pPr algn="ctr">
-                        <a:defRPr sz="1200">
-                          <a:solidFill>
-                            <a:srgbClr val="1A1A2E"/>
-                          </a:solidFill>
-                          <a:latin typeface="Calibri"/>
-                        </a:defRPr>
-                      </a:pPr>
-                      <a:r>
-                        <a:t>✓</a:t>
-                      </a:r>
-                    </a:p>
-                  </a:txBody>
-                  <a:tcPr/>
-                </a:tc>
-                <a:tc>
-                  <a:txBody>
-                    <a:bodyPr/>
-                    <a:lstStyle/>
-                    <a:p>
-                      <a:pPr algn="ctr">
-                        <a:defRPr sz="1200">
-                          <a:solidFill>
-                            <a:srgbClr val="1A1A2E"/>
-                          </a:solidFill>
-                          <a:latin typeface="Calibri"/>
-                        </a:defRPr>
-                      </a:pPr>
-                      <a:r>
-                        <a:t>✓</a:t>
-                      </a:r>
-                    </a:p>
-                  </a:txBody>
-                  <a:tcPr/>
-                </a:tc>
-              </a:tr>
-              <a:tr h="400050">
-                <a:tc>
-                  <a:txBody>
-                    <a:bodyPr/>
-                    <a:lstStyle/>
-                    <a:p>
-                      <a:pPr algn="ctr">
-                        <a:defRPr sz="1200">
-                          <a:solidFill>
-                            <a:srgbClr val="1A1A2E"/>
-                          </a:solidFill>
-                          <a:latin typeface="Calibri"/>
-                        </a:defRPr>
-                      </a:pPr>
-                      <a:r>
-                        <a:t>Modbus Flood</a:t>
                       </a:r>
                     </a:p>
                   </a:txBody>
@@ -11418,6 +11616,28 @@
                     </a:solidFill>
                   </a:tcPr>
                 </a:tc>
+              </a:tr>
+              <a:tr h="386080">
+                <a:tc>
+                  <a:txBody>
+                    <a:bodyPr/>
+                    <a:lstStyle/>
+                    <a:p>
+                      <a:pPr algn="ctr">
+                        <a:defRPr sz="1200">
+                          <a:solidFill>
+                            <a:srgbClr val="1A1A2E"/>
+                          </a:solidFill>
+                          <a:latin typeface="Calibri"/>
+                        </a:defRPr>
+                      </a:pPr>
+                      <a:r>
+                        <a:t>Multi-Stage</a:t>
+                      </a:r>
+                    </a:p>
+                  </a:txBody>
+                  <a:tcPr/>
+                </a:tc>
                 <a:tc>
                   <a:txBody>
                     <a:bodyPr/>
@@ -11433,6 +11653,48 @@
                       </a:pPr>
                       <a:r>
                         <a:t>✓</a:t>
+                      </a:r>
+                    </a:p>
+                  </a:txBody>
+                  <a:tcPr/>
+                </a:tc>
+                <a:tc>
+                  <a:txBody>
+                    <a:bodyPr/>
+                    <a:lstStyle/>
+                    <a:p>
+                      <a:pPr algn="ctr">
+                        <a:defRPr sz="1200">
+                          <a:solidFill>
+                            <a:srgbClr val="1A1A2E"/>
+                          </a:solidFill>
+                          <a:latin typeface="Calibri"/>
+                        </a:defRPr>
+                      </a:pPr>
+                      <a:r>
+                        <a:t>✓</a:t>
+                      </a:r>
+                    </a:p>
+                  </a:txBody>
+                  <a:tcPr/>
+                </a:tc>
+              </a:tr>
+              <a:tr h="386080">
+                <a:tc>
+                  <a:txBody>
+                    <a:bodyPr/>
+                    <a:lstStyle/>
+                    <a:p>
+                      <a:pPr algn="ctr">
+                        <a:defRPr sz="1200">
+                          <a:solidFill>
+                            <a:srgbClr val="1A1A2E"/>
+                          </a:solidFill>
+                          <a:latin typeface="Calibri"/>
+                        </a:defRPr>
+                      </a:pPr>
+                      <a:r>
+                        <a:t>Rootkit</a:t>
                       </a:r>
                     </a:p>
                   </a:txBody>
@@ -11491,102 +11753,20 @@
                   </a:tcPr>
                 </a:tc>
               </a:tr>
-              <a:tr h="400050">
-                <a:tc>
-                  <a:txBody>
-                    <a:bodyPr/>
-                    <a:lstStyle/>
-                    <a:p>
-                      <a:pPr algn="ctr">
-                        <a:defRPr sz="1200">
-                          <a:solidFill>
-                            <a:srgbClr val="1A1A2E"/>
-                          </a:solidFill>
-                          <a:latin typeface="Calibri"/>
-                        </a:defRPr>
-                      </a:pPr>
-                      <a:r>
-                        <a:t>Multi-Stage</a:t>
-                      </a:r>
-                    </a:p>
-                  </a:txBody>
-                  <a:tcPr/>
-                </a:tc>
-                <a:tc>
-                  <a:txBody>
-                    <a:bodyPr/>
-                    <a:lstStyle/>
-                    <a:p>
-                      <a:pPr algn="ctr">
-                        <a:defRPr sz="1200">
-                          <a:solidFill>
-                            <a:srgbClr val="1A1A2E"/>
-                          </a:solidFill>
-                          <a:latin typeface="Calibri"/>
-                        </a:defRPr>
-                      </a:pPr>
-                      <a:r>
-                        <a:t>✓</a:t>
-                      </a:r>
-                    </a:p>
-                  </a:txBody>
-                  <a:tcPr/>
-                </a:tc>
-                <a:tc>
-                  <a:txBody>
-                    <a:bodyPr/>
-                    <a:lstStyle/>
-                    <a:p>
-                      <a:pPr algn="ctr">
-                        <a:defRPr sz="1200">
-                          <a:solidFill>
-                            <a:srgbClr val="1A1A2E"/>
-                          </a:solidFill>
-                          <a:latin typeface="Calibri"/>
-                        </a:defRPr>
-                      </a:pPr>
-                      <a:r>
-                        <a:t>✓</a:t>
-                      </a:r>
-                    </a:p>
-                  </a:txBody>
-                  <a:tcPr/>
-                </a:tc>
-                <a:tc>
-                  <a:txBody>
-                    <a:bodyPr/>
-                    <a:lstStyle/>
-                    <a:p>
-                      <a:pPr algn="ctr">
-                        <a:defRPr sz="1200">
-                          <a:solidFill>
-                            <a:srgbClr val="1A1A2E"/>
-                          </a:solidFill>
-                          <a:latin typeface="Calibri"/>
-                        </a:defRPr>
-                      </a:pPr>
-                      <a:r>
-                        <a:t>✓</a:t>
-                      </a:r>
-                    </a:p>
-                  </a:txBody>
-                  <a:tcPr/>
-                </a:tc>
-              </a:tr>
             </a:tbl>
           </a:graphicData>
         </a:graphic>
       </p:graphicFrame>
       <p:sp>
         <p:nvSpPr>
-          <p:cNvPr id="17" name="TextBox 16"/>
+          <p:cNvPr id="21" name="TextBox 20"/>
           <p:cNvSpPr txBox="1"/>
           <p:nvPr/>
         </p:nvSpPr>
         <p:spPr>
           <a:xfrm>
             <a:off x="457200" y="3383280"/>
-            <a:ext cx="7772400" cy="365760"/>
+            <a:ext cx="9144000" cy="365760"/>
           </a:xfrm>
           <a:prstGeom prst="rect">
             <a:avLst/>
@@ -11615,14 +11795,14 @@
       </p:sp>
       <p:sp>
         <p:nvSpPr>
-          <p:cNvPr id="18" name="TextBox 17"/>
+          <p:cNvPr id="22" name="TextBox 21"/>
           <p:cNvSpPr txBox="1"/>
           <p:nvPr/>
         </p:nvSpPr>
         <p:spPr>
           <a:xfrm>
             <a:off x="457200" y="3840480"/>
-            <a:ext cx="7772400" cy="2560320"/>
+            <a:ext cx="9144000" cy="2560320"/>
           </a:xfrm>
           <a:prstGeom prst="rect">
             <a:avLst/>
@@ -11650,7 +11830,7 @@
               </a:defRPr>
             </a:pPr>
             <a:r>
-              <a:t>•  Wireshark: pcap analysis with Modbus TCP dissector (modbus.func_code filter)</a:t>
+              <a:t>•  Wireshark: Modbus TCP dissector, FC filters, I/O graphs, conversation stats (14 screenshots)</a:t>
             </a:r>
           </a:p>
           <a:p>
@@ -11669,7 +11849,7 @@
               </a:defRPr>
             </a:pPr>
             <a:r>
-              <a:t>•  tcpdump: live packet capture on loopback port 5502 during attack sequence</a:t>
+              <a:t>•  tcpdump: live packet capture on loopback port 5502 (3.5 MB, 38,289 packets)</a:t>
             </a:r>
           </a:p>
           <a:p>
@@ -11688,7 +11868,7 @@
               </a:defRPr>
             </a:pPr>
             <a:r>
-              <a:t>•  Custom IDS monitor: 3-layer real-time alert generation with JSON structured output</a:t>
+              <a:t>•  Custom IDS: 4-layer real-time detection (rules + rate + CPS physics + CNN+LSTM)</a:t>
             </a:r>
           </a:p>
           <a:p>
@@ -11707,7 +11887,7 @@
               </a:defRPr>
             </a:pPr>
             <a:r>
-              <a:t>•  Attack manifest: JSON timestamps for precise correlation of alerts to attack phases</a:t>
+              <a:t>•  System artifacts: 19 PLC register snapshots, process lists, network connections</a:t>
             </a:r>
           </a:p>
           <a:p>
@@ -11726,7 +11906,7 @@
               </a:defRPr>
             </a:pPr>
             <a:r>
-              <a:t>•  Key finding: multi-layer detection achieves 100% attack coverage — every attack type detected by all 3 layers</a:t>
+              <a:t>•  100% attack coverage — all 8 attacks detected by ML; 6/8 by CPS physics engine</a:t>
             </a:r>
           </a:p>
         </p:txBody>
@@ -11877,7 +12057,7 @@
               </a:defRPr>
             </a:pPr>
             <a:r>
-              <a:t>•  Multi-layer defence-in-depth (rules + rate + ML)</a:t>
+              <a:t>•  4-layer defence-in-depth (rules + rate + CPS physics + ML)</a:t>
             </a:r>
           </a:p>
           <a:p>

</xml_diff>